<commit_message>
Detalha metricas GQM nos slides do PC1
Co-authored-by: Copilot <223556219+Copilot@users.noreply.github.com>
</commit_message>
<xml_diff>
--- a/docs/apresentacao_pc1.pptx
+++ b/docs/apresentacao_pc1.pptx
@@ -8926,49 +8926,49 @@
         </p:nvSpPr>
         <p:spPr>
           <a:xfrm>
-            <a:off x="6464808" y="4370832"/>
-            <a:ext cx="4681728" cy="704088"/>
-          </a:xfrm>
-          <a:prstGeom prst="rect">
-            <a:avLst/>
-          </a:prstGeom>
-          <a:noFill/>
-        </p:spPr>
-        <p:txBody>
-          <a:bodyPr wrap="square" lIns="18288" rIns="18288" tIns="18288" bIns="18288" anchor="t">
-            <a:spAutoFit/>
-          </a:bodyPr>
-          <a:lstStyle/>
-          <a:p>
-            <a:pPr algn="l">
-              <a:spcAft>
-                <a:spcPts val="200"/>
-              </a:spcAft>
-            </a:pPr>
-            <a:r>
-              <a:rPr sz="1100" b="0" i="0">
+            <a:off x="6464808" y="4315968"/>
+            <a:ext cx="4681728" cy="1005840"/>
+          </a:xfrm>
+          <a:prstGeom prst="rect">
+            <a:avLst/>
+          </a:prstGeom>
+          <a:noFill/>
+        </p:spPr>
+        <p:txBody>
+          <a:bodyPr wrap="square" lIns="18288" rIns="18288" tIns="18288" bIns="18288" anchor="t">
+            <a:spAutoFit/>
+          </a:bodyPr>
+          <a:lstStyle/>
+          <a:p>
+            <a:pPr algn="l">
+              <a:spcAft>
+                <a:spcPts val="200"/>
+              </a:spcAft>
+            </a:pPr>
+            <a:r>
+              <a:rPr sz="1050" b="0" i="0">
                 <a:solidFill>
                   <a:srgbClr val="1E3348"/>
                 </a:solidFill>
                 <a:latin typeface="Aptos"/>
               </a:rPr>
-              <a:t>M5 · DDOM  · Defeitos operacionais por mil movimentações.</a:t>
-            </a:r>
-          </a:p>
-          <a:p>
-            <a:pPr algn="l">
-              <a:spcAft>
-                <a:spcPts val="200"/>
-              </a:spcAft>
-            </a:pPr>
-            <a:r>
-              <a:rPr sz="1100" b="0" i="0">
+              <a:t>M5 · DDOM | Produção, 90 dias: incidentes confirmados ÷ movimentações concluídas × 1.000.</a:t>
+            </a:r>
+          </a:p>
+          <a:p>
+            <a:pPr algn="l">
+              <a:spcAft>
+                <a:spcPts val="200"/>
+              </a:spcAft>
+            </a:pPr>
+            <a:r>
+              <a:rPr sz="1050" b="0" i="0">
                 <a:solidFill>
                   <a:srgbClr val="1E3348"/>
                 </a:solidFill>
                 <a:latin typeface="Aptos"/>
               </a:rPr>
-              <a:t>M6 · CVPB  · Backup e restauração verificável.</a:t>
+              <a:t>M6 · CVPB | Restaurações bem-sucedidas ÷ planejadas × 100%; validar pmieducar, modules e cadastro.</a:t>
             </a:r>
           </a:p>
         </p:txBody>
@@ -9457,96 +9457,96 @@
         <p:spPr>
           <a:xfrm>
             <a:off x="813816" y="2368296"/>
-            <a:ext cx="4791456" cy="1783080"/>
-          </a:xfrm>
-          <a:prstGeom prst="rect">
-            <a:avLst/>
-          </a:prstGeom>
-          <a:noFill/>
-        </p:spPr>
-        <p:txBody>
-          <a:bodyPr wrap="square" lIns="18288" rIns="18288" tIns="18288" bIns="18288" anchor="t">
-            <a:spAutoFit/>
-          </a:bodyPr>
-          <a:lstStyle/>
-          <a:p>
-            <a:pPr algn="l">
-              <a:spcAft>
-                <a:spcPts val="200"/>
-              </a:spcAft>
-            </a:pPr>
-            <a:r>
-              <a:rPr sz="1200" b="0" i="0">
+            <a:ext cx="4791456" cy="2148840"/>
+          </a:xfrm>
+          <a:prstGeom prst="rect">
+            <a:avLst/>
+          </a:prstGeom>
+          <a:noFill/>
+        </p:spPr>
+        <p:txBody>
+          <a:bodyPr wrap="square" lIns="18288" rIns="18288" tIns="18288" bIns="18288" anchor="t">
+            <a:spAutoFit/>
+          </a:bodyPr>
+          <a:lstStyle/>
+          <a:p>
+            <a:pPr algn="l">
+              <a:spcAft>
+                <a:spcPts val="200"/>
+              </a:spcAft>
+            </a:pPr>
+            <a:r>
+              <a:rPr sz="1050" b="0" i="0">
                 <a:solidFill>
                   <a:srgbClr val="1E3348"/>
                 </a:solidFill>
                 <a:latin typeface="Aptos"/>
               </a:rPr>
-              <a:t>M7a/b  Complexidade ciclomática (P90 e máximo)</a:t>
-            </a:r>
-          </a:p>
-          <a:p>
-            <a:pPr algn="l">
-              <a:spcAft>
-                <a:spcPts val="200"/>
-              </a:spcAft>
-            </a:pPr>
-            <a:r>
-              <a:rPr sz="1200" b="0" i="0">
+              <a:t>M7a/b · CC: P90 e máximo de v(G) por método/função.</a:t>
+            </a:r>
+          </a:p>
+          <a:p>
+            <a:pPr algn="l">
+              <a:spcAft>
+                <a:spcPts val="200"/>
+              </a:spcAft>
+            </a:pPr>
+            <a:r>
+              <a:rPr sz="1050" b="0" i="0">
                 <a:solidFill>
                   <a:srgbClr val="1E3348"/>
                 </a:solidFill>
                 <a:latin typeface="Aptos"/>
               </a:rPr>
-              <a:t>M8  Distância da sequência principal (acoplamento)</a:t>
-            </a:r>
-          </a:p>
-          <a:p>
-            <a:pPr algn="l">
-              <a:spcAft>
-                <a:spcPts val="200"/>
-              </a:spcAft>
-            </a:pPr>
-            <a:r>
-              <a:rPr sz="1200" b="0" i="0">
+              <a:t>M8 · DSPM: média de |A + I - 1| por componente.</a:t>
+            </a:r>
+          </a:p>
+          <a:p>
+            <a:pPr algn="l">
+              <a:spcAft>
+                <a:spcPts val="200"/>
+              </a:spcAft>
+            </a:pPr>
+            <a:r>
+              <a:rPr sz="1050" b="0" i="0">
                 <a:solidFill>
                   <a:srgbClr val="1E3348"/>
                 </a:solidFill>
                 <a:latin typeface="Aptos"/>
               </a:rPr>
-              <a:t>M9  Fricção de dados entre legado e moderno</a:t>
-            </a:r>
-          </a:p>
-          <a:p>
-            <a:pPr algn="l">
-              <a:spcAft>
-                <a:spcPts val="200"/>
-              </a:spcAft>
-            </a:pPr>
-            <a:r>
-              <a:rPr sz="1200" b="0" i="0">
+              <a:t>M9 · IFDL: média de adaptadores defensivos por modelo.</a:t>
+            </a:r>
+          </a:p>
+          <a:p>
+            <a:pPr algn="l">
+              <a:spcAft>
+                <a:spcPts val="200"/>
+              </a:spcAft>
+            </a:pPr>
+            <a:r>
+              <a:rPr sz="1050" b="0" i="0">
                 <a:solidFill>
                   <a:srgbClr val="1E3348"/>
                 </a:solidFill>
                 <a:latin typeface="Aptos"/>
               </a:rPr>
-              <a:t>M10  Índice de manutenibilidade</a:t>
-            </a:r>
-          </a:p>
-          <a:p>
-            <a:pPr algn="l">
-              <a:spcAft>
-                <a:spcPts val="200"/>
-              </a:spcAft>
-            </a:pPr>
-            <a:r>
-              <a:rPr sz="1200" b="0" i="0">
+              <a:t>M10 · MI: média normalizada por método (0 a 100).</a:t>
+            </a:r>
+          </a:p>
+          <a:p>
+            <a:pPr algn="l">
+              <a:spcAft>
+                <a:spcPts val="200"/>
+              </a:spcAft>
+            </a:pPr>
+            <a:r>
+              <a:rPr sz="1050" b="0" i="0">
                 <a:solidFill>
                   <a:srgbClr val="1E3348"/>
                 </a:solidFill>
                 <a:latin typeface="Aptos"/>
               </a:rPr>
-              <a:t>M11  Testes ativos e eficazes de domínio</a:t>
+              <a:t>M11 · TTAE: testes ativos com asserção ÷ casos declarados × 100%.</a:t>
             </a:r>
           </a:p>
         </p:txBody>
@@ -9604,7 +9604,7 @@
         </p:nvSpPr>
         <p:spPr>
           <a:xfrm>
-            <a:off x="914400" y="4507992"/>
+            <a:off x="914400" y="4590288"/>
             <a:ext cx="4590288" cy="201168"/>
           </a:xfrm>
           <a:prstGeom prst="rect">
@@ -9728,80 +9728,80 @@
         <p:spPr>
           <a:xfrm>
             <a:off x="6464808" y="2368296"/>
-            <a:ext cx="4754880" cy="1353312"/>
-          </a:xfrm>
-          <a:prstGeom prst="rect">
-            <a:avLst/>
-          </a:prstGeom>
-          <a:noFill/>
-        </p:spPr>
-        <p:txBody>
-          <a:bodyPr wrap="square" lIns="18288" rIns="18288" tIns="18288" bIns="18288" anchor="t">
-            <a:spAutoFit/>
-          </a:bodyPr>
-          <a:lstStyle/>
-          <a:p>
-            <a:pPr algn="l">
-              <a:spcAft>
-                <a:spcPts val="200"/>
-              </a:spcAft>
-            </a:pPr>
-            <a:r>
-              <a:rPr sz="1200" b="0" i="0">
+            <a:ext cx="4754880" cy="2057400"/>
+          </a:xfrm>
+          <a:prstGeom prst="rect">
+            <a:avLst/>
+          </a:prstGeom>
+          <a:noFill/>
+        </p:spPr>
+        <p:txBody>
+          <a:bodyPr wrap="square" lIns="18288" rIns="18288" tIns="18288" bIns="18288" anchor="t">
+            <a:spAutoFit/>
+          </a:bodyPr>
+          <a:lstStyle/>
+          <a:p>
+            <a:pPr algn="l">
+              <a:spcAft>
+                <a:spcPts val="200"/>
+              </a:spcAft>
+            </a:pPr>
+            <a:r>
+              <a:rPr sz="1019" b="0" i="0">
                 <a:solidFill>
                   <a:srgbClr val="1E3348"/>
                 </a:solidFill>
                 <a:latin typeface="Aptos"/>
               </a:rPr>
-              <a:t>M12  Proteção contra entradas inválidas  [GATE]</a:t>
-            </a:r>
-          </a:p>
-          <a:p>
-            <a:pPr algn="l">
-              <a:spcAft>
-                <a:spcPts val="200"/>
-              </a:spcAft>
-            </a:pPr>
-            <a:r>
-              <a:rPr sz="1200" b="0" i="0">
+              <a:t>M12 · IPPE [GATE]: cenários inválidos bloqueados com segurança ÷ cenários submetidos × 100%.</a:t>
+            </a:r>
+          </a:p>
+          <a:p>
+            <a:pPr algn="l">
+              <a:spcAft>
+                <a:spcPts val="200"/>
+              </a:spcAft>
+            </a:pPr>
+            <a:r>
+              <a:rPr sz="1019" b="0" i="0">
                 <a:solidFill>
                   <a:srgbClr val="1E3348"/>
                 </a:solidFill>
                 <a:latin typeface="Aptos"/>
               </a:rPr>
-              <a:t>M13  Clareza e ação corretiva nas mensagens</a:t>
-            </a:r>
-          </a:p>
-          <a:p>
-            <a:pPr algn="l">
-              <a:spcAft>
-                <a:spcPts val="200"/>
-              </a:spcAft>
-            </a:pPr>
-            <a:r>
-              <a:rPr sz="1200" b="0" i="0">
+              <a:t>M13 · ADMV: mensagens com causa e ação corretiva ÷ mensagens avaliadas × 100%.</a:t>
+            </a:r>
+          </a:p>
+          <a:p>
+            <a:pPr algn="l">
+              <a:spcAft>
+                <a:spcPts val="200"/>
+              </a:spcAft>
+            </a:pPr>
+            <a:r>
+              <a:rPr sz="1019" b="0" i="0">
                 <a:solidFill>
                   <a:srgbClr val="1E3348"/>
                 </a:solidFill>
                 <a:latin typeface="Aptos"/>
               </a:rPr>
-              <a:t>M14a/b  Tempo para concluir cada tarefa</a:t>
-            </a:r>
-          </a:p>
-          <a:p>
-            <a:pPr algn="l">
-              <a:spcAft>
-                <a:spcPts val="200"/>
-              </a:spcAft>
-            </a:pPr>
-            <a:r>
-              <a:rPr sz="1200" b="0" i="0">
+              <a:t>M14a/b · TMET: média em minutos por tarefa; comparar à referência treinada.</a:t>
+            </a:r>
+          </a:p>
+          <a:p>
+            <a:pPr algn="l">
+              <a:spcAft>
+                <a:spcPts val="200"/>
+              </a:spcAft>
+            </a:pPr>
+            <a:r>
+              <a:rPr sz="1019" b="0" i="0">
                 <a:solidFill>
                   <a:srgbClr val="1E3348"/>
                 </a:solidFill>
                 <a:latin typeface="Aptos"/>
               </a:rPr>
-              <a:t>M15  Sucesso correto na primeira submissão</a:t>
+              <a:t>M15 · TSPT: execuções corretas na 1ª submissão ÷ execuções totais × 100%.</a:t>
             </a:r>
           </a:p>
         </p:txBody>
@@ -9859,8 +9859,8 @@
         </p:nvSpPr>
         <p:spPr>
           <a:xfrm>
-            <a:off x="6583680" y="4096512"/>
-            <a:ext cx="4572000" cy="484632"/>
+            <a:off x="6583680" y="4526280"/>
+            <a:ext cx="4572000" cy="566928"/>
           </a:xfrm>
           <a:prstGeom prst="rect">
             <a:avLst/>
@@ -10037,8 +10037,8 @@
         </p:nvSpPr>
         <p:spPr>
           <a:xfrm>
-            <a:off x="758952" y="6199632"/>
-            <a:ext cx="10607040" cy="201168"/>
+            <a:off x="758952" y="5943600"/>
+            <a:ext cx="10607040" cy="384048"/>
           </a:xfrm>
           <a:prstGeom prst="rect">
             <a:avLst/>
@@ -10063,7 +10063,7 @@
                 </a:solidFill>
                 <a:latin typeface="Aptos"/>
               </a:rPr>
-              <a:t>M14 compara com referência treinada; M15 combina o resultado das duas tarefas.</a:t>
+              <a:t>M11 mede atividade com asserção; eficácia exige análise de mutação separada. M14 usa a média de três execuções treinadas como referência.</a:t>
             </a:r>
           </a:p>
         </p:txBody>

</xml_diff>